<commit_message>
Fix the garbled English title on the architecture slide
"A example real, Architecture Application" was Spanish word order translated
run by run: the hand-made slide splits its title into six runs, and each was
swapped for its Spanish counterpart in place. All six carry identical
formatting, so the split carried no meaning and the title now sits in one run
reading "A real example: application architecture", matching the sibling slide's
"A real example, end to end".

Fixed in manual_slides_EN.pptx, which is the source, and in the one stale
translations_en.py entry the harvest had picked up from the same slide.
</commit_message>
<xml_diff>
--- a/presentacion/Claude_Code_Presentacion_EN.pptx
+++ b/presentacion/Claude_Code_Presentacion_EN.pptx
@@ -46850,52 +46850,7 @@
                 </a:solidFill>
                 <a:latin typeface="Segoe UI"/>
               </a:rPr>
-              <a:t>A </a:t>
-            </a:r>
-            <a:r>
-              <a:rPr sz="3000" b="1" dirty="0" err="1">
-                <a:solidFill>
-                  <a:srgbClr val="E8EAED"/>
-                </a:solidFill>
-                <a:latin typeface="Segoe UI"/>
-              </a:rPr>
-              <a:t>example</a:t>
-            </a:r>
-            <a:r>
-              <a:rPr sz="3000" b="1" dirty="0">
-                <a:solidFill>
-                  <a:srgbClr val="E8EAED"/>
-                </a:solidFill>
-                <a:latin typeface="Segoe UI"/>
-              </a:rPr>
-              <a:t> real, </a:t>
-            </a:r>
-            <a:r>
-              <a:rPr lang="en-GB" sz="3000" b="1" dirty="0" err="1">
-                <a:solidFill>
-                  <a:srgbClr val="E8EAED"/>
-                </a:solidFill>
-                <a:latin typeface="Segoe UI"/>
-              </a:rPr>
-              <a:t>Architecture</a:t>
-            </a:r>
-            <a:r>
-              <a:rPr lang="en-GB" sz="3000" b="1" dirty="0">
-                <a:solidFill>
-                  <a:srgbClr val="E8EAED"/>
-                </a:solidFill>
-                <a:latin typeface="Segoe UI"/>
-              </a:rPr>
-              <a:t> </a:t>
-            </a:r>
-            <a:r>
-              <a:rPr lang="en-GB" sz="3000" b="1" dirty="0" err="1">
-                <a:solidFill>
-                  <a:srgbClr val="E8EAED"/>
-                </a:solidFill>
-                <a:latin typeface="Segoe UI"/>
-              </a:rPr>
-              <a:t>Application</a:t>
+              <a:t>A real example: application architecture</a:t>
             </a:r>
             <a:endParaRPr sz="3000" b="1" dirty="0">
               <a:solidFill>

</xml_diff>